<commit_message>
Regenerate A0 IDEF0 vNext in reference frame style
Rebuild ATMOS_A0_IDEF0_native_vNext.pptx to match the accepted
reference visual style: thin black IDEF0 border, centered title,
Node:A0 title-block cell at lower-right, no distribution/parent/footer
text. New layout per spec: A1-A4 main row with A5/A6 stacked at right.
All ICOMs/flows on correct IDEF0 sides; native elbow connectors,
arrowheads, and invisible ports; >=10pt fonts. Geometry self-audit
passes (orthogonal, perpendicular, no arrowheads inside boxes).

Co-Authored-By: Claude Opus 4.8 <noreply@anthropic.com>
Claude-Session: https://claude.ai/code/session_01HTptPbKo1SmoPv7tpyerKm
</commit_message>
<xml_diff>
--- a/ATMOS_A0_IDEF0_native_vNext.pptx
+++ b/ATMOS_A0_IDEF0_native_vNext.pptx
@@ -3096,8 +3096,138 @@
         </p:nvSpPr>
         <p:spPr>
           <a:xfrm>
-            <a:off x="1188720" y="3154680"/>
-            <a:ext cx="1280160" cy="868680"/>
+            <a:off x="320040" y="502920"/>
+            <a:ext cx="9418320" cy="6812280"/>
+          </a:xfrm>
+          <a:prstGeom prst="rect">
+            <a:avLst/>
+          </a:prstGeom>
+          <a:noFill/>
+          <a:ln w="15875">
+            <a:solidFill>
+              <a:srgbClr val="000000"/>
+            </a:solidFill>
+          </a:ln>
+          <a:effectLst/>
+        </p:spPr>
+        <p:style>
+          <a:lnRef idx="1">
+            <a:schemeClr val="accent1"/>
+          </a:lnRef>
+          <a:fillRef idx="3">
+            <a:schemeClr val="accent1"/>
+          </a:fillRef>
+          <a:effectRef idx="2">
+            <a:schemeClr val="accent1"/>
+          </a:effectRef>
+          <a:fontRef idx="minor">
+            <a:schemeClr val="lt1"/>
+          </a:fontRef>
+        </p:style>
+        <p:txBody>
+          <a:bodyPr rtlCol="0" anchor="ctr"/>
+          <a:lstStyle/>
+          <a:p>
+            <a:pPr algn="ctr"/>
+          </a:p>
+        </p:txBody>
+      </p:sp>
+      <p:sp>
+        <p:nvSpPr>
+          <p:cNvPr id="3" name="TextBox 2"/>
+          <p:cNvSpPr txBox="1"/>
+          <p:nvPr/>
+        </p:nvSpPr>
+        <p:spPr>
+          <a:xfrm>
+            <a:off x="320040" y="548640"/>
+            <a:ext cx="9418320" cy="310896"/>
+          </a:xfrm>
+          <a:prstGeom prst="rect">
+            <a:avLst/>
+          </a:prstGeom>
+          <a:noFill/>
+        </p:spPr>
+        <p:txBody>
+          <a:bodyPr wrap="square" anchor="t" lIns="12700" rIns="12700" tIns="12700" bIns="12700">
+            <a:spAutoFit/>
+          </a:bodyPr>
+          <a:lstStyle/>
+          <a:p>
+            <a:pPr algn="ctr"/>
+            <a:r>
+              <a:rPr sz="1500" b="1">
+                <a:solidFill>
+                  <a:srgbClr val="000000"/>
+                </a:solidFill>
+              </a:rPr>
+              <a:t>A0 — Decompose Conduct Air-Focused Weather Exploitation Operations</a:t>
+            </a:r>
+          </a:p>
+        </p:txBody>
+      </p:sp>
+      <p:sp>
+        <p:nvSpPr>
+          <p:cNvPr id="4" name="Rectangle 3"/>
+          <p:cNvSpPr/>
+          <p:nvPr/>
+        </p:nvSpPr>
+        <p:spPr>
+          <a:xfrm>
+            <a:off x="8321040" y="6967728"/>
+            <a:ext cx="1325880" cy="274320"/>
+          </a:xfrm>
+          <a:prstGeom prst="rect">
+            <a:avLst/>
+          </a:prstGeom>
+          <a:noFill/>
+          <a:ln w="12700">
+            <a:solidFill>
+              <a:srgbClr val="000000"/>
+            </a:solidFill>
+          </a:ln>
+          <a:effectLst/>
+        </p:spPr>
+        <p:style>
+          <a:lnRef idx="1">
+            <a:schemeClr val="accent1"/>
+          </a:lnRef>
+          <a:fillRef idx="3">
+            <a:schemeClr val="accent1"/>
+          </a:fillRef>
+          <a:effectRef idx="2">
+            <a:schemeClr val="accent1"/>
+          </a:effectRef>
+          <a:fontRef idx="minor">
+            <a:schemeClr val="lt1"/>
+          </a:fontRef>
+        </p:style>
+        <p:txBody>
+          <a:bodyPr rtlCol="0" anchor="ctr"/>
+          <a:lstStyle/>
+          <a:p>
+            <a:pPr algn="ctr"/>
+            <a:r>
+              <a:rPr sz="1100" b="1">
+                <a:solidFill>
+                  <a:srgbClr val="000000"/>
+                </a:solidFill>
+              </a:rPr>
+              <a:t>Node: A0</a:t>
+            </a:r>
+          </a:p>
+        </p:txBody>
+      </p:sp>
+      <p:sp>
+        <p:nvSpPr>
+          <p:cNvPr id="5" name="Rectangle 4"/>
+          <p:cNvSpPr/>
+          <p:nvPr/>
+        </p:nvSpPr>
+        <p:spPr>
+          <a:xfrm>
+            <a:off x="1051560" y="3383280"/>
+            <a:ext cx="1234440" cy="685800"/>
           </a:xfrm>
           <a:prstGeom prst="rect">
             <a:avLst/>
@@ -3143,7 +3273,7 @@
           <a:p>
             <a:pPr algn="ctr"/>
             <a:r>
-              <a:rPr sz="1000" b="0">
+              <a:rPr sz="1000">
                 <a:solidFill>
                   <a:srgbClr val="000000"/>
                 </a:solidFill>
@@ -3155,14 +3285,14 @@
       </p:sp>
       <p:sp>
         <p:nvSpPr>
-          <p:cNvPr id="3" name="Rectangle 2"/>
+          <p:cNvPr id="6" name="Rectangle 5"/>
           <p:cNvSpPr/>
           <p:nvPr/>
         </p:nvSpPr>
         <p:spPr>
           <a:xfrm>
-            <a:off x="2761488" y="3154680"/>
-            <a:ext cx="1280160" cy="868680"/>
+            <a:off x="2560320" y="3383280"/>
+            <a:ext cx="1234440" cy="685800"/>
           </a:xfrm>
           <a:prstGeom prst="rect">
             <a:avLst/>
@@ -3208,7 +3338,7 @@
           <a:p>
             <a:pPr algn="ctr"/>
             <a:r>
-              <a:rPr sz="1000" b="0">
+              <a:rPr sz="1000">
                 <a:solidFill>
                   <a:srgbClr val="000000"/>
                 </a:solidFill>
@@ -3220,14 +3350,14 @@
       </p:sp>
       <p:sp>
         <p:nvSpPr>
-          <p:cNvPr id="4" name="Rectangle 3"/>
+          <p:cNvPr id="7" name="Rectangle 6"/>
           <p:cNvSpPr/>
           <p:nvPr/>
         </p:nvSpPr>
         <p:spPr>
           <a:xfrm>
-            <a:off x="4334256" y="3154680"/>
-            <a:ext cx="1280160" cy="868680"/>
+            <a:off x="4069080" y="3383280"/>
+            <a:ext cx="1234440" cy="685800"/>
           </a:xfrm>
           <a:prstGeom prst="rect">
             <a:avLst/>
@@ -3273,7 +3403,7 @@
           <a:p>
             <a:pPr algn="ctr"/>
             <a:r>
-              <a:rPr sz="1000" b="0">
+              <a:rPr sz="1000">
                 <a:solidFill>
                   <a:srgbClr val="000000"/>
                 </a:solidFill>
@@ -3285,14 +3415,14 @@
       </p:sp>
       <p:sp>
         <p:nvSpPr>
-          <p:cNvPr id="5" name="Rectangle 4"/>
+          <p:cNvPr id="8" name="Rectangle 7"/>
           <p:cNvSpPr/>
           <p:nvPr/>
         </p:nvSpPr>
         <p:spPr>
           <a:xfrm>
-            <a:off x="5907024" y="3154680"/>
-            <a:ext cx="1280160" cy="868680"/>
+            <a:off x="5532120" y="3383280"/>
+            <a:ext cx="1417320" cy="685800"/>
           </a:xfrm>
           <a:prstGeom prst="rect">
             <a:avLst/>
@@ -3338,7 +3468,7 @@
           <a:p>
             <a:pPr algn="ctr"/>
             <a:r>
-              <a:rPr sz="1000" b="0">
+              <a:rPr sz="1000">
                 <a:solidFill>
                   <a:srgbClr val="000000"/>
                 </a:solidFill>
@@ -3350,14 +3480,14 @@
       </p:sp>
       <p:sp>
         <p:nvSpPr>
-          <p:cNvPr id="6" name="Rectangle 5"/>
+          <p:cNvPr id="9" name="Rectangle 8"/>
           <p:cNvSpPr/>
           <p:nvPr/>
         </p:nvSpPr>
         <p:spPr>
           <a:xfrm>
-            <a:off x="7863840" y="2308860"/>
-            <a:ext cx="1280160" cy="868680"/>
+            <a:off x="7543800" y="2148840"/>
+            <a:ext cx="1371600" cy="685800"/>
           </a:xfrm>
           <a:prstGeom prst="rect">
             <a:avLst/>
@@ -3403,7 +3533,7 @@
           <a:p>
             <a:pPr algn="ctr"/>
             <a:r>
-              <a:rPr sz="1000" b="0">
+              <a:rPr sz="1000">
                 <a:solidFill>
                   <a:srgbClr val="000000"/>
                 </a:solidFill>
@@ -3415,14 +3545,14 @@
       </p:sp>
       <p:sp>
         <p:nvSpPr>
-          <p:cNvPr id="7" name="Rectangle 6"/>
+          <p:cNvPr id="10" name="Rectangle 9"/>
           <p:cNvSpPr/>
           <p:nvPr/>
         </p:nvSpPr>
         <p:spPr>
           <a:xfrm>
-            <a:off x="7863840" y="4000500"/>
-            <a:ext cx="1280160" cy="868680"/>
+            <a:off x="7543800" y="4800600"/>
+            <a:ext cx="1371600" cy="685800"/>
           </a:xfrm>
           <a:prstGeom prst="rect">
             <a:avLst/>
@@ -3468,7 +3598,7 @@
           <a:p>
             <a:pPr algn="ctr"/>
             <a:r>
-              <a:rPr sz="1000" b="0">
+              <a:rPr sz="1000">
                 <a:solidFill>
                   <a:srgbClr val="000000"/>
                 </a:solidFill>
@@ -3480,14 +3610,14 @@
       </p:sp>
       <p:cxnSp>
         <p:nvCxnSpPr>
-          <p:cNvPr id="8" name="Connector 7"/>
+          <p:cNvPr id="11" name="Connector 10"/>
           <p:cNvCxnSpPr/>
           <p:nvPr/>
         </p:nvCxnSpPr>
         <p:spPr>
           <a:xfrm>
-            <a:off x="182880" y="3337560"/>
-            <a:ext cx="1005840" cy="0"/>
+            <a:off x="502920" y="3566160"/>
+            <a:ext cx="548640" cy="0"/>
           </a:xfrm>
           <a:prstGeom prst="bentConnector3">
             <a:avLst/>
@@ -3517,13 +3647,13 @@
       </p:cxnSp>
       <p:sp>
         <p:nvSpPr>
-          <p:cNvPr id="9" name="Rectangle 8"/>
+          <p:cNvPr id="12" name="Rectangle 11"/>
           <p:cNvSpPr/>
           <p:nvPr/>
         </p:nvSpPr>
         <p:spPr>
           <a:xfrm>
-            <a:off x="1172718" y="3321558"/>
+            <a:off x="1035557" y="3550158"/>
             <a:ext cx="32004" cy="32004"/>
           </a:xfrm>
           <a:prstGeom prst="rect">
@@ -3559,14 +3689,14 @@
       </p:sp>
       <p:cxnSp>
         <p:nvCxnSpPr>
-          <p:cNvPr id="10" name="Connector 9"/>
+          <p:cNvPr id="13" name="Connector 12"/>
           <p:cNvCxnSpPr/>
           <p:nvPr/>
         </p:nvCxnSpPr>
         <p:spPr>
           <a:xfrm>
-            <a:off x="182880" y="3794760"/>
-            <a:ext cx="1005840" cy="0"/>
+            <a:off x="502920" y="3913632"/>
+            <a:ext cx="548640" cy="0"/>
           </a:xfrm>
           <a:prstGeom prst="bentConnector3">
             <a:avLst/>
@@ -3596,13 +3726,13 @@
       </p:cxnSp>
       <p:sp>
         <p:nvSpPr>
-          <p:cNvPr id="11" name="Rectangle 10"/>
+          <p:cNvPr id="14" name="Rectangle 13"/>
           <p:cNvSpPr/>
           <p:nvPr/>
         </p:nvSpPr>
         <p:spPr>
           <a:xfrm>
-            <a:off x="1172718" y="3778758"/>
+            <a:off x="1035557" y="3897630"/>
             <a:ext cx="32004" cy="32004"/>
           </a:xfrm>
           <a:prstGeom prst="rect">
@@ -3638,14 +3768,14 @@
       </p:sp>
       <p:cxnSp>
         <p:nvCxnSpPr>
-          <p:cNvPr id="12" name="Connector 11"/>
+          <p:cNvPr id="15" name="Connector 14"/>
           <p:cNvCxnSpPr/>
           <p:nvPr/>
         </p:nvCxnSpPr>
         <p:spPr>
           <a:xfrm>
-            <a:off x="182880" y="2788920"/>
-            <a:ext cx="7452360" cy="0"/>
+            <a:off x="502920" y="2103120"/>
+            <a:ext cx="6812280" cy="0"/>
           </a:xfrm>
           <a:prstGeom prst="bentConnector3">
             <a:avLst/>
@@ -3674,14 +3804,14 @@
       </p:cxnSp>
       <p:cxnSp>
         <p:nvCxnSpPr>
-          <p:cNvPr id="13" name="Connector 12"/>
+          <p:cNvPr id="16" name="Connector 15"/>
           <p:cNvCxnSpPr/>
           <p:nvPr/>
         </p:nvCxnSpPr>
         <p:spPr>
           <a:xfrm>
-            <a:off x="7635240" y="2788920"/>
-            <a:ext cx="0" cy="228600"/>
+            <a:off x="7315200" y="2103120"/>
+            <a:ext cx="0" cy="548640"/>
           </a:xfrm>
           <a:prstGeom prst="bentConnector3">
             <a:avLst/>
@@ -3710,13 +3840,13 @@
       </p:cxnSp>
       <p:cxnSp>
         <p:nvCxnSpPr>
-          <p:cNvPr id="14" name="Connector 13"/>
+          <p:cNvPr id="17" name="Connector 16"/>
           <p:cNvCxnSpPr/>
           <p:nvPr/>
         </p:nvCxnSpPr>
         <p:spPr>
           <a:xfrm>
-            <a:off x="7635240" y="3017520"/>
+            <a:off x="7315200" y="2651760"/>
             <a:ext cx="228600" cy="0"/>
           </a:xfrm>
           <a:prstGeom prst="bentConnector3">
@@ -3747,13 +3877,13 @@
       </p:cxnSp>
       <p:sp>
         <p:nvSpPr>
-          <p:cNvPr id="15" name="Rectangle 14"/>
+          <p:cNvPr id="18" name="Rectangle 17"/>
           <p:cNvSpPr/>
           <p:nvPr/>
         </p:nvSpPr>
         <p:spPr>
           <a:xfrm>
-            <a:off x="7847838" y="3001518"/>
+            <a:off x="7527798" y="2635758"/>
             <a:ext cx="32004" cy="32004"/>
           </a:xfrm>
           <a:prstGeom prst="rect">
@@ -3789,14 +3919,14 @@
       </p:sp>
       <p:cxnSp>
         <p:nvCxnSpPr>
-          <p:cNvPr id="16" name="Connector 15"/>
+          <p:cNvPr id="19" name="Connector 18"/>
           <p:cNvCxnSpPr/>
           <p:nvPr/>
         </p:nvCxnSpPr>
         <p:spPr>
           <a:xfrm>
-            <a:off x="7635240" y="2788920"/>
-            <a:ext cx="0" cy="1508760"/>
+            <a:off x="7315200" y="2103120"/>
+            <a:ext cx="0" cy="3200400"/>
           </a:xfrm>
           <a:prstGeom prst="bentConnector3">
             <a:avLst/>
@@ -3825,13 +3955,13 @@
       </p:cxnSp>
       <p:cxnSp>
         <p:nvCxnSpPr>
-          <p:cNvPr id="17" name="Connector 16"/>
+          <p:cNvPr id="20" name="Connector 19"/>
           <p:cNvCxnSpPr/>
           <p:nvPr/>
         </p:nvCxnSpPr>
         <p:spPr>
           <a:xfrm>
-            <a:off x="7635240" y="4297680"/>
+            <a:off x="7315200" y="5303520"/>
             <a:ext cx="228600" cy="0"/>
           </a:xfrm>
           <a:prstGeom prst="bentConnector3">
@@ -3862,13 +3992,13 @@
       </p:cxnSp>
       <p:sp>
         <p:nvSpPr>
-          <p:cNvPr id="18" name="Rectangle 17"/>
+          <p:cNvPr id="21" name="Rectangle 20"/>
           <p:cNvSpPr/>
           <p:nvPr/>
         </p:nvSpPr>
         <p:spPr>
           <a:xfrm>
-            <a:off x="7847838" y="4281678"/>
+            <a:off x="7527798" y="5287518"/>
             <a:ext cx="32004" cy="32004"/>
           </a:xfrm>
           <a:prstGeom prst="rect">
@@ -3904,14 +4034,14 @@
       </p:sp>
       <p:sp>
         <p:nvSpPr>
-          <p:cNvPr id="19" name="TextBox 18"/>
+          <p:cNvPr id="22" name="TextBox 21"/>
           <p:cNvSpPr txBox="1"/>
           <p:nvPr/>
         </p:nvSpPr>
         <p:spPr>
           <a:xfrm>
-            <a:off x="36576" y="2907792"/>
-            <a:ext cx="1078992" cy="411480"/>
+            <a:off x="411480" y="3054096"/>
+            <a:ext cx="1828800" cy="274320"/>
           </a:xfrm>
           <a:prstGeom prst="rect">
             <a:avLst/>
@@ -3919,7 +4049,7 @@
           <a:noFill/>
         </p:spPr>
         <p:txBody>
-          <a:bodyPr wrap="square" anchor="t" lIns="12700" rIns="12700" tIns="0" bIns="0">
+          <a:bodyPr wrap="square" anchor="t" lIns="12700" rIns="12700" tIns="12700" bIns="12700">
             <a:spAutoFit/>
           </a:bodyPr>
           <a:lstStyle/>
@@ -3938,14 +4068,14 @@
       </p:sp>
       <p:sp>
         <p:nvSpPr>
-          <p:cNvPr id="20" name="TextBox 19"/>
+          <p:cNvPr id="23" name="TextBox 22"/>
           <p:cNvSpPr txBox="1"/>
           <p:nvPr/>
         </p:nvSpPr>
         <p:spPr>
           <a:xfrm>
-            <a:off x="36576" y="3822191"/>
-            <a:ext cx="1078992" cy="411480"/>
+            <a:off x="384048" y="4160520"/>
+            <a:ext cx="960120" cy="365760"/>
           </a:xfrm>
           <a:prstGeom prst="rect">
             <a:avLst/>
@@ -3953,7 +4083,7 @@
           <a:noFill/>
         </p:spPr>
         <p:txBody>
-          <a:bodyPr wrap="square" anchor="t" lIns="12700" rIns="12700" tIns="0" bIns="0">
+          <a:bodyPr wrap="square" anchor="t" lIns="12700" rIns="12700" tIns="12700" bIns="12700">
             <a:spAutoFit/>
           </a:bodyPr>
           <a:lstStyle/>
@@ -3972,14 +4102,14 @@
       </p:sp>
       <p:sp>
         <p:nvSpPr>
-          <p:cNvPr id="21" name="TextBox 20"/>
+          <p:cNvPr id="24" name="TextBox 23"/>
           <p:cNvSpPr txBox="1"/>
           <p:nvPr/>
         </p:nvSpPr>
         <p:spPr>
           <a:xfrm>
-            <a:off x="36576" y="2331720"/>
-            <a:ext cx="1188720" cy="411480"/>
+            <a:off x="384048" y="1847088"/>
+            <a:ext cx="1874519" cy="237744"/>
           </a:xfrm>
           <a:prstGeom prst="rect">
             <a:avLst/>
@@ -3987,7 +4117,7 @@
           <a:noFill/>
         </p:spPr>
         <p:txBody>
-          <a:bodyPr wrap="square" anchor="t" lIns="12700" rIns="12700" tIns="0" bIns="0">
+          <a:bodyPr wrap="square" anchor="t" lIns="12700" rIns="12700" tIns="12700" bIns="12700">
             <a:spAutoFit/>
           </a:bodyPr>
           <a:lstStyle/>
@@ -4006,14 +4136,14 @@
       </p:sp>
       <p:cxnSp>
         <p:nvCxnSpPr>
-          <p:cNvPr id="22" name="Connector 21"/>
+          <p:cNvPr id="25" name="Connector 24"/>
           <p:cNvCxnSpPr/>
           <p:nvPr/>
         </p:nvCxnSpPr>
         <p:spPr>
           <a:xfrm>
-            <a:off x="1920240" y="868680"/>
-            <a:ext cx="0" cy="457200"/>
+            <a:off x="1920240" y="1188720"/>
+            <a:ext cx="0" cy="91440"/>
           </a:xfrm>
           <a:prstGeom prst="bentConnector3">
             <a:avLst/>
@@ -4042,14 +4172,14 @@
       </p:cxnSp>
       <p:cxnSp>
         <p:nvCxnSpPr>
-          <p:cNvPr id="23" name="Connector 22"/>
+          <p:cNvPr id="26" name="Connector 25"/>
           <p:cNvCxnSpPr/>
           <p:nvPr/>
         </p:nvCxnSpPr>
         <p:spPr>
           <a:xfrm>
-            <a:off x="1920240" y="1325880"/>
-            <a:ext cx="6263639" cy="0"/>
+            <a:off x="1920240" y="1280160"/>
+            <a:ext cx="7635240" cy="0"/>
           </a:xfrm>
           <a:prstGeom prst="bentConnector3">
             <a:avLst/>
@@ -4078,14 +4208,14 @@
       </p:cxnSp>
       <p:cxnSp>
         <p:nvCxnSpPr>
-          <p:cNvPr id="24" name="Connector 23"/>
+          <p:cNvPr id="27" name="Connector 26"/>
           <p:cNvCxnSpPr/>
           <p:nvPr/>
         </p:nvCxnSpPr>
         <p:spPr>
           <a:xfrm>
-            <a:off x="8183879" y="1325880"/>
-            <a:ext cx="0" cy="982980"/>
+            <a:off x="7955279" y="1280160"/>
+            <a:ext cx="0" cy="868680"/>
           </a:xfrm>
           <a:prstGeom prst="bentConnector3">
             <a:avLst/>
@@ -4115,13 +4245,13 @@
       </p:cxnSp>
       <p:sp>
         <p:nvSpPr>
-          <p:cNvPr id="25" name="Rectangle 24"/>
+          <p:cNvPr id="28" name="Rectangle 27"/>
           <p:cNvSpPr/>
           <p:nvPr/>
         </p:nvSpPr>
         <p:spPr>
           <a:xfrm>
-            <a:off x="8167877" y="2292858"/>
+            <a:off x="7939277" y="2132838"/>
             <a:ext cx="32004" cy="32004"/>
           </a:xfrm>
           <a:prstGeom prst="rect">
@@ -4157,14 +4287,14 @@
       </p:sp>
       <p:cxnSp>
         <p:nvCxnSpPr>
-          <p:cNvPr id="26" name="Connector 25"/>
+          <p:cNvPr id="29" name="Connector 28"/>
           <p:cNvCxnSpPr/>
           <p:nvPr/>
         </p:nvCxnSpPr>
         <p:spPr>
           <a:xfrm>
-            <a:off x="7498079" y="1325880"/>
-            <a:ext cx="0" cy="2377440"/>
+            <a:off x="9555480" y="1280160"/>
+            <a:ext cx="0" cy="3383280"/>
           </a:xfrm>
           <a:prstGeom prst="bentConnector3">
             <a:avLst/>
@@ -4193,14 +4323,14 @@
       </p:cxnSp>
       <p:cxnSp>
         <p:nvCxnSpPr>
-          <p:cNvPr id="27" name="Connector 26"/>
+          <p:cNvPr id="30" name="Connector 29"/>
           <p:cNvCxnSpPr/>
           <p:nvPr/>
         </p:nvCxnSpPr>
         <p:spPr>
-          <a:xfrm>
-            <a:off x="7498079" y="3703320"/>
-            <a:ext cx="685800" cy="0"/>
+          <a:xfrm flipH="1">
+            <a:off x="7955279" y="4663440"/>
+            <a:ext cx="1600201" cy="0"/>
           </a:xfrm>
           <a:prstGeom prst="bentConnector3">
             <a:avLst/>
@@ -4229,14 +4359,14 @@
       </p:cxnSp>
       <p:cxnSp>
         <p:nvCxnSpPr>
-          <p:cNvPr id="28" name="Connector 27"/>
+          <p:cNvPr id="31" name="Connector 30"/>
           <p:cNvCxnSpPr/>
           <p:nvPr/>
         </p:nvCxnSpPr>
         <p:spPr>
           <a:xfrm>
-            <a:off x="8183879" y="3703320"/>
-            <a:ext cx="0" cy="297180"/>
+            <a:off x="7955279" y="4663440"/>
+            <a:ext cx="0" cy="137160"/>
           </a:xfrm>
           <a:prstGeom prst="bentConnector3">
             <a:avLst/>
@@ -4266,13 +4396,13 @@
       </p:cxnSp>
       <p:sp>
         <p:nvSpPr>
-          <p:cNvPr id="29" name="Rectangle 28"/>
+          <p:cNvPr id="32" name="Rectangle 31"/>
           <p:cNvSpPr/>
           <p:nvPr/>
         </p:nvSpPr>
         <p:spPr>
           <a:xfrm>
-            <a:off x="8167877" y="3984498"/>
+            <a:off x="7939277" y="4784598"/>
             <a:ext cx="32004" cy="32004"/>
           </a:xfrm>
           <a:prstGeom prst="rect">
@@ -4308,14 +4438,14 @@
       </p:sp>
       <p:cxnSp>
         <p:nvCxnSpPr>
-          <p:cNvPr id="30" name="Connector 29"/>
+          <p:cNvPr id="33" name="Connector 32"/>
           <p:cNvCxnSpPr/>
           <p:nvPr/>
         </p:nvCxnSpPr>
         <p:spPr>
           <a:xfrm>
-            <a:off x="7498079" y="1325880"/>
-            <a:ext cx="685800" cy="0"/>
+            <a:off x="4754880" y="1188720"/>
+            <a:ext cx="0" cy="320040"/>
           </a:xfrm>
           <a:prstGeom prst="bentConnector3">
             <a:avLst/>
@@ -4344,14 +4474,14 @@
       </p:cxnSp>
       <p:cxnSp>
         <p:nvCxnSpPr>
-          <p:cNvPr id="31" name="Connector 30"/>
+          <p:cNvPr id="34" name="Connector 33"/>
           <p:cNvCxnSpPr/>
           <p:nvPr/>
         </p:nvCxnSpPr>
         <p:spPr>
           <a:xfrm>
-            <a:off x="4663440" y="1005840"/>
-            <a:ext cx="0" cy="640080"/>
+            <a:off x="4754880" y="1508760"/>
+            <a:ext cx="4919472" cy="0"/>
           </a:xfrm>
           <a:prstGeom prst="bentConnector3">
             <a:avLst/>
@@ -4380,50 +4510,14 @@
       </p:cxnSp>
       <p:cxnSp>
         <p:nvCxnSpPr>
-          <p:cNvPr id="32" name="Connector 31"/>
+          <p:cNvPr id="35" name="Connector 34"/>
           <p:cNvCxnSpPr/>
           <p:nvPr/>
         </p:nvCxnSpPr>
         <p:spPr>
           <a:xfrm>
-            <a:off x="4663440" y="1645920"/>
-            <a:ext cx="4069080" cy="0"/>
-          </a:xfrm>
-          <a:prstGeom prst="bentConnector3">
-            <a:avLst/>
-          </a:prstGeom>
-          <a:ln w="15875">
-            <a:solidFill>
-              <a:srgbClr val="000000"/>
-            </a:solidFill>
-          </a:ln>
-          <a:effectLst/>
-        </p:spPr>
-        <p:style>
-          <a:lnRef idx="2">
-            <a:schemeClr val="accent1"/>
-          </a:lnRef>
-          <a:fillRef idx="0">
-            <a:schemeClr val="accent1"/>
-          </a:fillRef>
-          <a:effectRef idx="1">
-            <a:schemeClr val="accent1"/>
-          </a:effectRef>
-          <a:fontRef idx="minor">
-            <a:schemeClr val="tx1"/>
-          </a:fontRef>
-        </p:style>
-      </p:cxnSp>
-      <p:cxnSp>
-        <p:nvCxnSpPr>
-          <p:cNvPr id="33" name="Connector 32"/>
-          <p:cNvCxnSpPr/>
-          <p:nvPr/>
-        </p:nvCxnSpPr>
-        <p:spPr>
-          <a:xfrm>
-            <a:off x="6272784" y="1645920"/>
-            <a:ext cx="0" cy="1508760"/>
+            <a:off x="5897880" y="1508760"/>
+            <a:ext cx="0" cy="1874520"/>
           </a:xfrm>
           <a:prstGeom prst="bentConnector3">
             <a:avLst/>
@@ -4453,13 +4547,13 @@
       </p:cxnSp>
       <p:sp>
         <p:nvSpPr>
-          <p:cNvPr id="34" name="Rectangle 33"/>
+          <p:cNvPr id="36" name="Rectangle 35"/>
           <p:cNvSpPr/>
           <p:nvPr/>
         </p:nvSpPr>
         <p:spPr>
           <a:xfrm>
-            <a:off x="6256782" y="3138678"/>
+            <a:off x="5881878" y="3367278"/>
             <a:ext cx="32004" cy="32004"/>
           </a:xfrm>
           <a:prstGeom prst="rect">
@@ -4495,14 +4589,14 @@
       </p:sp>
       <p:cxnSp>
         <p:nvCxnSpPr>
-          <p:cNvPr id="35" name="Connector 34"/>
+          <p:cNvPr id="37" name="Connector 36"/>
           <p:cNvCxnSpPr/>
           <p:nvPr/>
         </p:nvCxnSpPr>
         <p:spPr>
           <a:xfrm>
-            <a:off x="8732520" y="1645920"/>
-            <a:ext cx="0" cy="662940"/>
+            <a:off x="8595360" y="1508760"/>
+            <a:ext cx="0" cy="640080"/>
           </a:xfrm>
           <a:prstGeom prst="bentConnector3">
             <a:avLst/>
@@ -4532,13 +4626,13 @@
       </p:cxnSp>
       <p:sp>
         <p:nvSpPr>
-          <p:cNvPr id="36" name="Rectangle 35"/>
+          <p:cNvPr id="38" name="Rectangle 37"/>
           <p:cNvSpPr/>
           <p:nvPr/>
         </p:nvSpPr>
         <p:spPr>
           <a:xfrm>
-            <a:off x="8716518" y="2292858"/>
+            <a:off x="8579358" y="2132838"/>
             <a:ext cx="32004" cy="32004"/>
           </a:xfrm>
           <a:prstGeom prst="rect">
@@ -4574,14 +4668,14 @@
       </p:sp>
       <p:cxnSp>
         <p:nvCxnSpPr>
-          <p:cNvPr id="37" name="Connector 36"/>
+          <p:cNvPr id="39" name="Connector 38"/>
           <p:cNvCxnSpPr/>
           <p:nvPr/>
         </p:nvCxnSpPr>
         <p:spPr>
           <a:xfrm>
-            <a:off x="7680960" y="1645920"/>
-            <a:ext cx="0" cy="2176271"/>
+            <a:off x="9674352" y="1508760"/>
+            <a:ext cx="0" cy="3063240"/>
           </a:xfrm>
           <a:prstGeom prst="bentConnector3">
             <a:avLst/>
@@ -4610,14 +4704,14 @@
       </p:cxnSp>
       <p:cxnSp>
         <p:nvCxnSpPr>
-          <p:cNvPr id="38" name="Connector 37"/>
+          <p:cNvPr id="40" name="Connector 39"/>
           <p:cNvCxnSpPr/>
           <p:nvPr/>
         </p:nvCxnSpPr>
         <p:spPr>
-          <a:xfrm>
-            <a:off x="7680960" y="3822191"/>
-            <a:ext cx="1051560" cy="0"/>
+          <a:xfrm flipH="1">
+            <a:off x="8595360" y="4572000"/>
+            <a:ext cx="1078992" cy="0"/>
           </a:xfrm>
           <a:prstGeom prst="bentConnector3">
             <a:avLst/>
@@ -4646,14 +4740,14 @@
       </p:cxnSp>
       <p:cxnSp>
         <p:nvCxnSpPr>
-          <p:cNvPr id="39" name="Connector 38"/>
+          <p:cNvPr id="41" name="Connector 40"/>
           <p:cNvCxnSpPr/>
           <p:nvPr/>
         </p:nvCxnSpPr>
         <p:spPr>
           <a:xfrm>
-            <a:off x="8732520" y="3822191"/>
-            <a:ext cx="0" cy="178309"/>
+            <a:off x="8595360" y="4572000"/>
+            <a:ext cx="0" cy="228600"/>
           </a:xfrm>
           <a:prstGeom prst="bentConnector3">
             <a:avLst/>
@@ -4683,13 +4777,13 @@
       </p:cxnSp>
       <p:sp>
         <p:nvSpPr>
-          <p:cNvPr id="40" name="Rectangle 39"/>
+          <p:cNvPr id="42" name="Rectangle 41"/>
           <p:cNvSpPr/>
           <p:nvPr/>
         </p:nvSpPr>
         <p:spPr>
           <a:xfrm>
-            <a:off x="8716518" y="3984498"/>
+            <a:off x="8579358" y="4784598"/>
             <a:ext cx="32004" cy="32004"/>
           </a:xfrm>
           <a:prstGeom prst="rect">
@@ -4725,14 +4819,14 @@
       </p:sp>
       <p:cxnSp>
         <p:nvCxnSpPr>
-          <p:cNvPr id="41" name="Connector 40"/>
+          <p:cNvPr id="43" name="Connector 42"/>
           <p:cNvCxnSpPr/>
           <p:nvPr/>
         </p:nvCxnSpPr>
         <p:spPr>
           <a:xfrm>
-            <a:off x="7680960" y="1645920"/>
-            <a:ext cx="1051560" cy="0"/>
+            <a:off x="7315200" y="1188720"/>
+            <a:ext cx="0" cy="548640"/>
           </a:xfrm>
           <a:prstGeom prst="bentConnector3">
             <a:avLst/>
@@ -4761,14 +4855,14 @@
       </p:cxnSp>
       <p:cxnSp>
         <p:nvCxnSpPr>
-          <p:cNvPr id="42" name="Connector 41"/>
+          <p:cNvPr id="44" name="Connector 43"/>
           <p:cNvCxnSpPr/>
           <p:nvPr/>
         </p:nvCxnSpPr>
         <p:spPr>
           <a:xfrm>
-            <a:off x="6821424" y="1143000"/>
-            <a:ext cx="0" cy="822960"/>
+            <a:off x="6537960" y="1737360"/>
+            <a:ext cx="777240" cy="0"/>
           </a:xfrm>
           <a:prstGeom prst="bentConnector3">
             <a:avLst/>
@@ -4797,14 +4891,14 @@
       </p:cxnSp>
       <p:cxnSp>
         <p:nvCxnSpPr>
-          <p:cNvPr id="43" name="Connector 42"/>
+          <p:cNvPr id="45" name="Connector 44"/>
           <p:cNvCxnSpPr/>
           <p:nvPr/>
         </p:nvCxnSpPr>
         <p:spPr>
           <a:xfrm>
-            <a:off x="6821424" y="1965960"/>
-            <a:ext cx="0" cy="1188720"/>
+            <a:off x="6537960" y="1737360"/>
+            <a:ext cx="0" cy="1645920"/>
           </a:xfrm>
           <a:prstGeom prst="bentConnector3">
             <a:avLst/>
@@ -4834,13 +4928,13 @@
       </p:cxnSp>
       <p:sp>
         <p:nvSpPr>
-          <p:cNvPr id="44" name="Rectangle 43"/>
+          <p:cNvPr id="46" name="Rectangle 45"/>
           <p:cNvSpPr/>
           <p:nvPr/>
         </p:nvSpPr>
         <p:spPr>
           <a:xfrm>
-            <a:off x="6805422" y="3138678"/>
+            <a:off x="6521958" y="3367278"/>
             <a:ext cx="32004" cy="32004"/>
           </a:xfrm>
           <a:prstGeom prst="rect">
@@ -4876,14 +4970,14 @@
       </p:sp>
       <p:sp>
         <p:nvSpPr>
-          <p:cNvPr id="45" name="TextBox 44"/>
+          <p:cNvPr id="47" name="TextBox 46"/>
           <p:cNvSpPr txBox="1"/>
           <p:nvPr/>
         </p:nvSpPr>
         <p:spPr>
           <a:xfrm>
-            <a:off x="548640" y="502920"/>
-            <a:ext cx="2834640" cy="365760"/>
+            <a:off x="502920" y="932688"/>
+            <a:ext cx="3017520" cy="256032"/>
           </a:xfrm>
           <a:prstGeom prst="rect">
             <a:avLst/>
@@ -4891,7 +4985,7 @@
           <a:noFill/>
         </p:spPr>
         <p:txBody>
-          <a:bodyPr wrap="square" anchor="t" lIns="12700" rIns="12700" tIns="0" bIns="0">
+          <a:bodyPr wrap="square" anchor="t" lIns="12700" rIns="12700" tIns="12700" bIns="12700">
             <a:spAutoFit/>
           </a:bodyPr>
           <a:lstStyle/>
@@ -4910,14 +5004,14 @@
       </p:sp>
       <p:sp>
         <p:nvSpPr>
-          <p:cNvPr id="46" name="TextBox 45"/>
+          <p:cNvPr id="48" name="TextBox 47"/>
           <p:cNvSpPr txBox="1"/>
           <p:nvPr/>
         </p:nvSpPr>
         <p:spPr>
           <a:xfrm>
-            <a:off x="3520440" y="502920"/>
-            <a:ext cx="2377440" cy="365760"/>
+            <a:off x="3611880" y="932688"/>
+            <a:ext cx="2331720" cy="256032"/>
           </a:xfrm>
           <a:prstGeom prst="rect">
             <a:avLst/>
@@ -4925,7 +5019,7 @@
           <a:noFill/>
         </p:spPr>
         <p:txBody>
-          <a:bodyPr wrap="square" anchor="t" lIns="12700" rIns="12700" tIns="0" bIns="0">
+          <a:bodyPr wrap="square" anchor="t" lIns="12700" rIns="12700" tIns="12700" bIns="12700">
             <a:spAutoFit/>
           </a:bodyPr>
           <a:lstStyle/>
@@ -4944,14 +5038,14 @@
       </p:sp>
       <p:sp>
         <p:nvSpPr>
-          <p:cNvPr id="47" name="TextBox 46"/>
+          <p:cNvPr id="49" name="TextBox 48"/>
           <p:cNvSpPr txBox="1"/>
           <p:nvPr/>
         </p:nvSpPr>
         <p:spPr>
           <a:xfrm>
-            <a:off x="5989320" y="502920"/>
-            <a:ext cx="2971800" cy="365760"/>
+            <a:off x="5989320" y="932688"/>
+            <a:ext cx="3200400" cy="256032"/>
           </a:xfrm>
           <a:prstGeom prst="rect">
             <a:avLst/>
@@ -4959,7 +5053,7 @@
           <a:noFill/>
         </p:spPr>
         <p:txBody>
-          <a:bodyPr wrap="square" anchor="t" lIns="12700" rIns="12700" tIns="0" bIns="0">
+          <a:bodyPr wrap="square" anchor="t" lIns="12700" rIns="12700" tIns="12700" bIns="12700">
             <a:spAutoFit/>
           </a:bodyPr>
           <a:lstStyle/>
@@ -4978,14 +5072,14 @@
       </p:sp>
       <p:cxnSp>
         <p:nvCxnSpPr>
-          <p:cNvPr id="48" name="Connector 47"/>
+          <p:cNvPr id="50" name="Connector 49"/>
           <p:cNvCxnSpPr/>
           <p:nvPr/>
         </p:nvCxnSpPr>
         <p:spPr>
           <a:xfrm>
-            <a:off x="2468880" y="3589020"/>
-            <a:ext cx="292608" cy="0"/>
+            <a:off x="2286000" y="3726180"/>
+            <a:ext cx="274320" cy="0"/>
           </a:xfrm>
           <a:prstGeom prst="bentConnector3">
             <a:avLst/>
@@ -5015,13 +5109,13 @@
       </p:cxnSp>
       <p:sp>
         <p:nvSpPr>
-          <p:cNvPr id="49" name="Rectangle 48"/>
+          <p:cNvPr id="51" name="Rectangle 50"/>
           <p:cNvSpPr/>
           <p:nvPr/>
         </p:nvSpPr>
         <p:spPr>
           <a:xfrm>
-            <a:off x="2745486" y="3573018"/>
+            <a:off x="2544318" y="3710178"/>
             <a:ext cx="32004" cy="32004"/>
           </a:xfrm>
           <a:prstGeom prst="rect">
@@ -5057,14 +5151,14 @@
       </p:sp>
       <p:cxnSp>
         <p:nvCxnSpPr>
-          <p:cNvPr id="50" name="Connector 49"/>
+          <p:cNvPr id="52" name="Connector 51"/>
           <p:cNvCxnSpPr/>
           <p:nvPr/>
         </p:nvCxnSpPr>
         <p:spPr>
           <a:xfrm>
-            <a:off x="4041648" y="3589020"/>
-            <a:ext cx="292608" cy="0"/>
+            <a:off x="3794760" y="3726180"/>
+            <a:ext cx="274320" cy="0"/>
           </a:xfrm>
           <a:prstGeom prst="bentConnector3">
             <a:avLst/>
@@ -5094,13 +5188,13 @@
       </p:cxnSp>
       <p:sp>
         <p:nvSpPr>
-          <p:cNvPr id="51" name="Rectangle 50"/>
+          <p:cNvPr id="53" name="Rectangle 52"/>
           <p:cNvSpPr/>
           <p:nvPr/>
         </p:nvSpPr>
         <p:spPr>
           <a:xfrm>
-            <a:off x="4318254" y="3573018"/>
+            <a:off x="4053078" y="3710178"/>
             <a:ext cx="32004" cy="32004"/>
           </a:xfrm>
           <a:prstGeom prst="rect">
@@ -5136,14 +5230,14 @@
       </p:sp>
       <p:cxnSp>
         <p:nvCxnSpPr>
-          <p:cNvPr id="52" name="Connector 51"/>
+          <p:cNvPr id="54" name="Connector 53"/>
           <p:cNvCxnSpPr/>
           <p:nvPr/>
         </p:nvCxnSpPr>
         <p:spPr>
           <a:xfrm>
-            <a:off x="5614416" y="3589020"/>
-            <a:ext cx="292608" cy="0"/>
+            <a:off x="5303520" y="3726180"/>
+            <a:ext cx="228600" cy="0"/>
           </a:xfrm>
           <a:prstGeom prst="bentConnector3">
             <a:avLst/>
@@ -5173,13 +5267,13 @@
       </p:cxnSp>
       <p:sp>
         <p:nvSpPr>
-          <p:cNvPr id="53" name="Rectangle 52"/>
+          <p:cNvPr id="55" name="Rectangle 54"/>
           <p:cNvSpPr/>
           <p:nvPr/>
         </p:nvSpPr>
         <p:spPr>
           <a:xfrm>
-            <a:off x="5891022" y="3573018"/>
+            <a:off x="5516118" y="3710178"/>
             <a:ext cx="32004" cy="32004"/>
           </a:xfrm>
           <a:prstGeom prst="rect">
@@ -5215,14 +5309,14 @@
       </p:sp>
       <p:cxnSp>
         <p:nvCxnSpPr>
-          <p:cNvPr id="54" name="Connector 53"/>
+          <p:cNvPr id="56" name="Connector 55"/>
           <p:cNvCxnSpPr/>
           <p:nvPr/>
         </p:nvCxnSpPr>
         <p:spPr>
           <a:xfrm>
-            <a:off x="7187183" y="3291840"/>
-            <a:ext cx="219457" cy="0"/>
+            <a:off x="6949440" y="3566160"/>
+            <a:ext cx="274320" cy="0"/>
           </a:xfrm>
           <a:prstGeom prst="bentConnector3">
             <a:avLst/>
@@ -5251,14 +5345,14 @@
       </p:cxnSp>
       <p:cxnSp>
         <p:nvCxnSpPr>
-          <p:cNvPr id="55" name="Connector 54"/>
+          <p:cNvPr id="57" name="Connector 56"/>
           <p:cNvCxnSpPr/>
           <p:nvPr/>
         </p:nvCxnSpPr>
         <p:spPr>
           <a:xfrm flipV="1">
-            <a:off x="7406640" y="2834640"/>
-            <a:ext cx="0" cy="457200"/>
+            <a:off x="7223760" y="2423160"/>
+            <a:ext cx="0" cy="1143000"/>
           </a:xfrm>
           <a:prstGeom prst="bentConnector3">
             <a:avLst/>
@@ -5287,14 +5381,14 @@
       </p:cxnSp>
       <p:cxnSp>
         <p:nvCxnSpPr>
-          <p:cNvPr id="56" name="Connector 55"/>
+          <p:cNvPr id="58" name="Connector 57"/>
           <p:cNvCxnSpPr/>
           <p:nvPr/>
         </p:nvCxnSpPr>
         <p:spPr>
           <a:xfrm>
-            <a:off x="7406640" y="2834640"/>
-            <a:ext cx="457200" cy="0"/>
+            <a:off x="7223760" y="2423160"/>
+            <a:ext cx="320040" cy="0"/>
           </a:xfrm>
           <a:prstGeom prst="bentConnector3">
             <a:avLst/>
@@ -5324,13 +5418,13 @@
       </p:cxnSp>
       <p:sp>
         <p:nvSpPr>
-          <p:cNvPr id="57" name="Rectangle 56"/>
+          <p:cNvPr id="59" name="Rectangle 58"/>
           <p:cNvSpPr/>
           <p:nvPr/>
         </p:nvSpPr>
         <p:spPr>
           <a:xfrm>
-            <a:off x="7847838" y="2818638"/>
+            <a:off x="7527798" y="2407158"/>
             <a:ext cx="32004" cy="32004"/>
           </a:xfrm>
           <a:prstGeom prst="rect">
@@ -5366,14 +5460,14 @@
       </p:sp>
       <p:cxnSp>
         <p:nvCxnSpPr>
-          <p:cNvPr id="58" name="Connector 57"/>
+          <p:cNvPr id="60" name="Connector 59"/>
           <p:cNvCxnSpPr/>
           <p:nvPr/>
         </p:nvCxnSpPr>
         <p:spPr>
           <a:xfrm>
-            <a:off x="7187183" y="3886200"/>
-            <a:ext cx="265177" cy="0"/>
+            <a:off x="6949440" y="3913632"/>
+            <a:ext cx="274320" cy="0"/>
           </a:xfrm>
           <a:prstGeom prst="bentConnector3">
             <a:avLst/>
@@ -5402,14 +5496,14 @@
       </p:cxnSp>
       <p:cxnSp>
         <p:nvCxnSpPr>
-          <p:cNvPr id="59" name="Connector 58"/>
+          <p:cNvPr id="61" name="Connector 60"/>
           <p:cNvCxnSpPr/>
           <p:nvPr/>
         </p:nvCxnSpPr>
         <p:spPr>
           <a:xfrm>
-            <a:off x="7452360" y="3886200"/>
-            <a:ext cx="0" cy="274320"/>
+            <a:off x="7223760" y="3913632"/>
+            <a:ext cx="0" cy="1161288"/>
           </a:xfrm>
           <a:prstGeom prst="bentConnector3">
             <a:avLst/>
@@ -5438,14 +5532,14 @@
       </p:cxnSp>
       <p:cxnSp>
         <p:nvCxnSpPr>
-          <p:cNvPr id="60" name="Connector 59"/>
+          <p:cNvPr id="62" name="Connector 61"/>
           <p:cNvCxnSpPr/>
           <p:nvPr/>
         </p:nvCxnSpPr>
         <p:spPr>
           <a:xfrm>
-            <a:off x="7452360" y="4160520"/>
-            <a:ext cx="411480" cy="0"/>
+            <a:off x="7223760" y="5074920"/>
+            <a:ext cx="320040" cy="0"/>
           </a:xfrm>
           <a:prstGeom prst="bentConnector3">
             <a:avLst/>
@@ -5475,13 +5569,13 @@
       </p:cxnSp>
       <p:sp>
         <p:nvSpPr>
-          <p:cNvPr id="61" name="Rectangle 60"/>
+          <p:cNvPr id="63" name="Rectangle 62"/>
           <p:cNvSpPr/>
           <p:nvPr/>
         </p:nvSpPr>
         <p:spPr>
           <a:xfrm>
-            <a:off x="7847838" y="4144518"/>
+            <a:off x="7527798" y="5058918"/>
             <a:ext cx="32004" cy="32004"/>
           </a:xfrm>
           <a:prstGeom prst="rect">
@@ -5517,22 +5611,27 @@
       </p:sp>
       <p:sp>
         <p:nvSpPr>
-          <p:cNvPr id="62" name="TextBox 61"/>
+          <p:cNvPr id="64" name="TextBox 63"/>
           <p:cNvSpPr txBox="1"/>
           <p:nvPr/>
         </p:nvSpPr>
         <p:spPr>
           <a:xfrm>
-            <a:off x="1417320" y="4114800"/>
-            <a:ext cx="1783080" cy="502920"/>
+            <a:off x="1417320" y="2359152"/>
+            <a:ext cx="1783080" cy="384048"/>
           </a:xfrm>
           <a:prstGeom prst="rect">
             <a:avLst/>
           </a:prstGeom>
-          <a:noFill/>
-        </p:spPr>
-        <p:txBody>
-          <a:bodyPr wrap="square" anchor="t" lIns="12700" rIns="12700" tIns="0" bIns="0">
+          <a:solidFill>
+            <a:srgbClr val="FFFFFF"/>
+          </a:solidFill>
+          <a:ln>
+            <a:noFill/>
+          </a:ln>
+        </p:spPr>
+        <p:txBody>
+          <a:bodyPr wrap="square" anchor="t" lIns="12700" rIns="12700" tIns="12700" bIns="12700">
             <a:spAutoFit/>
           </a:bodyPr>
           <a:lstStyle/>
@@ -5551,22 +5650,27 @@
       </p:sp>
       <p:sp>
         <p:nvSpPr>
-          <p:cNvPr id="63" name="TextBox 62"/>
+          <p:cNvPr id="65" name="TextBox 64"/>
           <p:cNvSpPr txBox="1"/>
           <p:nvPr/>
         </p:nvSpPr>
         <p:spPr>
           <a:xfrm>
-            <a:off x="2990088" y="4114800"/>
-            <a:ext cx="1783080" cy="502920"/>
+            <a:off x="2971800" y="2670048"/>
+            <a:ext cx="1783080" cy="384048"/>
           </a:xfrm>
           <a:prstGeom prst="rect">
             <a:avLst/>
           </a:prstGeom>
-          <a:noFill/>
-        </p:spPr>
-        <p:txBody>
-          <a:bodyPr wrap="square" anchor="t" lIns="12700" rIns="12700" tIns="0" bIns="0">
+          <a:solidFill>
+            <a:srgbClr val="FFFFFF"/>
+          </a:solidFill>
+          <a:ln>
+            <a:noFill/>
+          </a:ln>
+        </p:spPr>
+        <p:txBody>
+          <a:bodyPr wrap="square" anchor="t" lIns="12700" rIns="12700" tIns="12700" bIns="12700">
             <a:spAutoFit/>
           </a:bodyPr>
           <a:lstStyle/>
@@ -5585,22 +5689,27 @@
       </p:sp>
       <p:sp>
         <p:nvSpPr>
-          <p:cNvPr id="64" name="TextBox 63"/>
+          <p:cNvPr id="66" name="TextBox 65"/>
           <p:cNvSpPr txBox="1"/>
           <p:nvPr/>
         </p:nvSpPr>
         <p:spPr>
           <a:xfrm>
-            <a:off x="4562856" y="4114800"/>
-            <a:ext cx="1783080" cy="502920"/>
+            <a:off x="4434840" y="2962656"/>
+            <a:ext cx="1783080" cy="384048"/>
           </a:xfrm>
           <a:prstGeom prst="rect">
             <a:avLst/>
           </a:prstGeom>
-          <a:noFill/>
-        </p:spPr>
-        <p:txBody>
-          <a:bodyPr wrap="square" anchor="t" lIns="12700" rIns="12700" tIns="0" bIns="0">
+          <a:solidFill>
+            <a:srgbClr val="FFFFFF"/>
+          </a:solidFill>
+          <a:ln>
+            <a:noFill/>
+          </a:ln>
+        </p:spPr>
+        <p:txBody>
+          <a:bodyPr wrap="square" anchor="t" lIns="12700" rIns="12700" tIns="12700" bIns="12700">
             <a:spAutoFit/>
           </a:bodyPr>
           <a:lstStyle/>
@@ -5619,22 +5728,27 @@
       </p:sp>
       <p:sp>
         <p:nvSpPr>
-          <p:cNvPr id="65" name="TextBox 64"/>
+          <p:cNvPr id="67" name="TextBox 66"/>
           <p:cNvSpPr txBox="1"/>
           <p:nvPr/>
         </p:nvSpPr>
         <p:spPr>
           <a:xfrm>
-            <a:off x="5760720" y="2395728"/>
-            <a:ext cx="1417320" cy="502920"/>
+            <a:off x="6967728" y="2980944"/>
+            <a:ext cx="1783080" cy="384048"/>
           </a:xfrm>
           <a:prstGeom prst="rect">
             <a:avLst/>
           </a:prstGeom>
-          <a:noFill/>
-        </p:spPr>
-        <p:txBody>
-          <a:bodyPr wrap="square" anchor="t" lIns="12700" rIns="12700" tIns="0" bIns="0">
+          <a:solidFill>
+            <a:srgbClr val="FFFFFF"/>
+          </a:solidFill>
+          <a:ln>
+            <a:noFill/>
+          </a:ln>
+        </p:spPr>
+        <p:txBody>
+          <a:bodyPr wrap="square" anchor="t" lIns="12700" rIns="12700" tIns="12700" bIns="12700">
             <a:spAutoFit/>
           </a:bodyPr>
           <a:lstStyle/>
@@ -5653,22 +5767,27 @@
       </p:sp>
       <p:sp>
         <p:nvSpPr>
-          <p:cNvPr id="66" name="TextBox 65"/>
+          <p:cNvPr id="68" name="TextBox 67"/>
           <p:cNvSpPr txBox="1"/>
           <p:nvPr/>
         </p:nvSpPr>
         <p:spPr>
           <a:xfrm>
-            <a:off x="5760720" y="4663440"/>
-            <a:ext cx="1417320" cy="502920"/>
+            <a:off x="6967728" y="4160520"/>
+            <a:ext cx="1783080" cy="384048"/>
           </a:xfrm>
           <a:prstGeom prst="rect">
             <a:avLst/>
           </a:prstGeom>
-          <a:noFill/>
-        </p:spPr>
-        <p:txBody>
-          <a:bodyPr wrap="square" anchor="t" lIns="12700" rIns="12700" tIns="0" bIns="0">
+          <a:solidFill>
+            <a:srgbClr val="FFFFFF"/>
+          </a:solidFill>
+          <a:ln>
+            <a:noFill/>
+          </a:ln>
+        </p:spPr>
+        <p:txBody>
+          <a:bodyPr wrap="square" anchor="t" lIns="12700" rIns="12700" tIns="12700" bIns="12700">
             <a:spAutoFit/>
           </a:bodyPr>
           <a:lstStyle/>
@@ -5687,14 +5806,14 @@
       </p:sp>
       <p:cxnSp>
         <p:nvCxnSpPr>
-          <p:cNvPr id="67" name="Connector 66"/>
+          <p:cNvPr id="69" name="Connector 68"/>
           <p:cNvCxnSpPr/>
           <p:nvPr/>
         </p:nvCxnSpPr>
         <p:spPr>
           <a:xfrm>
-            <a:off x="7187183" y="3589020"/>
-            <a:ext cx="2414017" cy="0"/>
+            <a:off x="6949440" y="3726180"/>
+            <a:ext cx="2697480" cy="0"/>
           </a:xfrm>
           <a:prstGeom prst="bentConnector3">
             <a:avLst/>
@@ -5724,13 +5843,13 @@
       </p:cxnSp>
       <p:sp>
         <p:nvSpPr>
-          <p:cNvPr id="68" name="Rectangle 67"/>
+          <p:cNvPr id="70" name="Rectangle 69"/>
           <p:cNvSpPr/>
           <p:nvPr/>
         </p:nvSpPr>
         <p:spPr>
           <a:xfrm>
-            <a:off x="9585198" y="3573018"/>
+            <a:off x="9630918" y="3710178"/>
             <a:ext cx="32004" cy="32004"/>
           </a:xfrm>
           <a:prstGeom prst="rect">
@@ -5766,14 +5885,14 @@
       </p:sp>
       <p:cxnSp>
         <p:nvCxnSpPr>
-          <p:cNvPr id="69" name="Connector 68"/>
+          <p:cNvPr id="71" name="Connector 70"/>
           <p:cNvCxnSpPr/>
           <p:nvPr/>
         </p:nvCxnSpPr>
         <p:spPr>
           <a:xfrm>
-            <a:off x="9144000" y="2743200"/>
-            <a:ext cx="457200" cy="0"/>
+            <a:off x="8915400" y="2491740"/>
+            <a:ext cx="731520" cy="0"/>
           </a:xfrm>
           <a:prstGeom prst="bentConnector3">
             <a:avLst/>
@@ -5803,13 +5922,13 @@
       </p:cxnSp>
       <p:sp>
         <p:nvSpPr>
-          <p:cNvPr id="70" name="Rectangle 69"/>
+          <p:cNvPr id="72" name="Rectangle 71"/>
           <p:cNvSpPr/>
           <p:nvPr/>
         </p:nvSpPr>
         <p:spPr>
           <a:xfrm>
-            <a:off x="9585198" y="2727198"/>
+            <a:off x="9630918" y="2475738"/>
             <a:ext cx="32004" cy="32004"/>
           </a:xfrm>
           <a:prstGeom prst="rect">
@@ -5845,14 +5964,14 @@
       </p:sp>
       <p:cxnSp>
         <p:nvCxnSpPr>
-          <p:cNvPr id="71" name="Connector 70"/>
+          <p:cNvPr id="73" name="Connector 72"/>
           <p:cNvCxnSpPr/>
           <p:nvPr/>
         </p:nvCxnSpPr>
         <p:spPr>
           <a:xfrm>
-            <a:off x="9144000" y="4434840"/>
-            <a:ext cx="457200" cy="0"/>
+            <a:off x="8915400" y="5143500"/>
+            <a:ext cx="731520" cy="0"/>
           </a:xfrm>
           <a:prstGeom prst="bentConnector3">
             <a:avLst/>
@@ -5882,13 +6001,13 @@
       </p:cxnSp>
       <p:sp>
         <p:nvSpPr>
-          <p:cNvPr id="72" name="Rectangle 71"/>
+          <p:cNvPr id="74" name="Rectangle 73"/>
           <p:cNvSpPr/>
           <p:nvPr/>
         </p:nvSpPr>
         <p:spPr>
           <a:xfrm>
-            <a:off x="9585198" y="4418838"/>
+            <a:off x="9630918" y="5127498"/>
             <a:ext cx="32004" cy="32004"/>
           </a:xfrm>
           <a:prstGeom prst="rect">
@@ -5924,22 +6043,27 @@
       </p:sp>
       <p:sp>
         <p:nvSpPr>
-          <p:cNvPr id="73" name="TextBox 72"/>
+          <p:cNvPr id="75" name="TextBox 74"/>
           <p:cNvSpPr txBox="1"/>
           <p:nvPr/>
         </p:nvSpPr>
         <p:spPr>
           <a:xfrm>
-            <a:off x="9162288" y="3200400"/>
-            <a:ext cx="868680" cy="365760"/>
+            <a:off x="7589520" y="3456432"/>
+            <a:ext cx="1783080" cy="237744"/>
           </a:xfrm>
           <a:prstGeom prst="rect">
             <a:avLst/>
           </a:prstGeom>
-          <a:noFill/>
-        </p:spPr>
-        <p:txBody>
-          <a:bodyPr wrap="square" anchor="t" lIns="12700" rIns="12700" tIns="0" bIns="0">
+          <a:solidFill>
+            <a:srgbClr val="FFFFFF"/>
+          </a:solidFill>
+          <a:ln>
+            <a:noFill/>
+          </a:ln>
+        </p:spPr>
+        <p:txBody>
+          <a:bodyPr wrap="square" anchor="t" lIns="12700" rIns="12700" tIns="12700" bIns="12700">
             <a:spAutoFit/>
           </a:bodyPr>
           <a:lstStyle/>
@@ -5958,22 +6082,27 @@
       </p:sp>
       <p:sp>
         <p:nvSpPr>
-          <p:cNvPr id="74" name="TextBox 73"/>
+          <p:cNvPr id="76" name="TextBox 75"/>
           <p:cNvSpPr txBox="1"/>
           <p:nvPr/>
         </p:nvSpPr>
         <p:spPr>
           <a:xfrm>
-            <a:off x="9162288" y="2240280"/>
-            <a:ext cx="868680" cy="502920"/>
+            <a:off x="8942832" y="2194560"/>
+            <a:ext cx="566928" cy="502920"/>
           </a:xfrm>
           <a:prstGeom prst="rect">
             <a:avLst/>
           </a:prstGeom>
-          <a:noFill/>
-        </p:spPr>
-        <p:txBody>
-          <a:bodyPr wrap="square" anchor="t" lIns="12700" rIns="12700" tIns="0" bIns="0">
+          <a:solidFill>
+            <a:srgbClr val="FFFFFF"/>
+          </a:solidFill>
+          <a:ln>
+            <a:noFill/>
+          </a:ln>
+        </p:spPr>
+        <p:txBody>
+          <a:bodyPr wrap="square" anchor="t" lIns="12700" rIns="12700" tIns="12700" bIns="12700">
             <a:spAutoFit/>
           </a:bodyPr>
           <a:lstStyle/>
@@ -5992,22 +6121,27 @@
       </p:sp>
       <p:sp>
         <p:nvSpPr>
-          <p:cNvPr id="75" name="TextBox 74"/>
+          <p:cNvPr id="77" name="TextBox 76"/>
           <p:cNvSpPr txBox="1"/>
           <p:nvPr/>
         </p:nvSpPr>
         <p:spPr>
           <a:xfrm>
-            <a:off x="9162288" y="4023360"/>
-            <a:ext cx="868680" cy="502920"/>
+            <a:off x="8942832" y="4846320"/>
+            <a:ext cx="566928" cy="502920"/>
           </a:xfrm>
           <a:prstGeom prst="rect">
             <a:avLst/>
           </a:prstGeom>
-          <a:noFill/>
-        </p:spPr>
-        <p:txBody>
-          <a:bodyPr wrap="square" anchor="t" lIns="12700" rIns="12700" tIns="0" bIns="0">
+          <a:solidFill>
+            <a:srgbClr val="FFFFFF"/>
+          </a:solidFill>
+          <a:ln>
+            <a:noFill/>
+          </a:ln>
+        </p:spPr>
+        <p:txBody>
+          <a:bodyPr wrap="square" anchor="t" lIns="12700" rIns="12700" tIns="12700" bIns="12700">
             <a:spAutoFit/>
           </a:bodyPr>
           <a:lstStyle/>
@@ -6026,86 +6160,14 @@
       </p:sp>
       <p:cxnSp>
         <p:nvCxnSpPr>
-          <p:cNvPr id="76" name="Connector 75"/>
-          <p:cNvCxnSpPr/>
-          <p:nvPr/>
-        </p:nvCxnSpPr>
-        <p:spPr>
-          <a:xfrm>
-            <a:off x="1645920" y="5577840"/>
-            <a:ext cx="6537959" cy="0"/>
-          </a:xfrm>
-          <a:prstGeom prst="bentConnector3">
-            <a:avLst/>
-          </a:prstGeom>
-          <a:ln w="15875">
-            <a:solidFill>
-              <a:srgbClr val="000000"/>
-            </a:solidFill>
-          </a:ln>
-          <a:effectLst/>
-        </p:spPr>
-        <p:style>
-          <a:lnRef idx="2">
-            <a:schemeClr val="accent1"/>
-          </a:lnRef>
-          <a:fillRef idx="0">
-            <a:schemeClr val="accent1"/>
-          </a:fillRef>
-          <a:effectRef idx="1">
-            <a:schemeClr val="accent1"/>
-          </a:effectRef>
-          <a:fontRef idx="minor">
-            <a:schemeClr val="tx1"/>
-          </a:fontRef>
-        </p:style>
-      </p:cxnSp>
-      <p:cxnSp>
-        <p:nvCxnSpPr>
-          <p:cNvPr id="77" name="Connector 76"/>
-          <p:cNvCxnSpPr/>
-          <p:nvPr/>
-        </p:nvCxnSpPr>
-        <p:spPr>
-          <a:xfrm>
-            <a:off x="3584448" y="5897880"/>
-            <a:ext cx="1572768" cy="0"/>
-          </a:xfrm>
-          <a:prstGeom prst="bentConnector3">
-            <a:avLst/>
-          </a:prstGeom>
-          <a:ln w="15875">
-            <a:solidFill>
-              <a:srgbClr val="000000"/>
-            </a:solidFill>
-          </a:ln>
-          <a:effectLst/>
-        </p:spPr>
-        <p:style>
-          <a:lnRef idx="2">
-            <a:schemeClr val="accent1"/>
-          </a:lnRef>
-          <a:fillRef idx="0">
-            <a:schemeClr val="accent1"/>
-          </a:fillRef>
-          <a:effectRef idx="1">
-            <a:schemeClr val="accent1"/>
-          </a:effectRef>
-          <a:fontRef idx="minor">
-            <a:schemeClr val="tx1"/>
-          </a:fontRef>
-        </p:style>
-      </p:cxnSp>
-      <p:cxnSp>
-        <p:nvCxnSpPr>
           <p:cNvPr id="78" name="Connector 77"/>
           <p:cNvCxnSpPr/>
           <p:nvPr/>
         </p:nvCxnSpPr>
         <p:spPr>
           <a:xfrm>
-            <a:off x="2103120" y="6217920"/>
-            <a:ext cx="6629400" cy="0"/>
+            <a:off x="1417320" y="6126480"/>
+            <a:ext cx="7680960" cy="0"/>
           </a:xfrm>
           <a:prstGeom prst="bentConnector3">
             <a:avLst/>
@@ -6139,9 +6201,81 @@
           <p:nvPr/>
         </p:nvCxnSpPr>
         <p:spPr>
+          <a:xfrm>
+            <a:off x="3429000" y="6446520"/>
+            <a:ext cx="1554480" cy="0"/>
+          </a:xfrm>
+          <a:prstGeom prst="bentConnector3">
+            <a:avLst/>
+          </a:prstGeom>
+          <a:ln w="15875">
+            <a:solidFill>
+              <a:srgbClr val="000000"/>
+            </a:solidFill>
+          </a:ln>
+          <a:effectLst/>
+        </p:spPr>
+        <p:style>
+          <a:lnRef idx="2">
+            <a:schemeClr val="accent1"/>
+          </a:lnRef>
+          <a:fillRef idx="0">
+            <a:schemeClr val="accent1"/>
+          </a:fillRef>
+          <a:effectRef idx="1">
+            <a:schemeClr val="accent1"/>
+          </a:effectRef>
+          <a:fontRef idx="minor">
+            <a:schemeClr val="tx1"/>
+          </a:fontRef>
+        </p:style>
+      </p:cxnSp>
+      <p:cxnSp>
+        <p:nvCxnSpPr>
+          <p:cNvPr id="80" name="Connector 79"/>
+          <p:cNvCxnSpPr/>
+          <p:nvPr/>
+        </p:nvCxnSpPr>
+        <p:spPr>
+          <a:xfrm>
+            <a:off x="1920240" y="6766560"/>
+            <a:ext cx="7360920" cy="0"/>
+          </a:xfrm>
+          <a:prstGeom prst="bentConnector3">
+            <a:avLst/>
+          </a:prstGeom>
+          <a:ln w="15875">
+            <a:solidFill>
+              <a:srgbClr val="000000"/>
+            </a:solidFill>
+          </a:ln>
+          <a:effectLst/>
+        </p:spPr>
+        <p:style>
+          <a:lnRef idx="2">
+            <a:schemeClr val="accent1"/>
+          </a:lnRef>
+          <a:fillRef idx="0">
+            <a:schemeClr val="accent1"/>
+          </a:fillRef>
+          <a:effectRef idx="1">
+            <a:schemeClr val="accent1"/>
+          </a:effectRef>
+          <a:fontRef idx="minor">
+            <a:schemeClr val="tx1"/>
+          </a:fontRef>
+        </p:style>
+      </p:cxnSp>
+      <p:cxnSp>
+        <p:nvCxnSpPr>
+          <p:cNvPr id="81" name="Connector 80"/>
+          <p:cNvCxnSpPr/>
+          <p:nvPr/>
+        </p:nvCxnSpPr>
+        <p:spPr>
           <a:xfrm flipV="1">
-            <a:off x="1645920" y="4023360"/>
-            <a:ext cx="0" cy="1554480"/>
+            <a:off x="1417320" y="4069080"/>
+            <a:ext cx="0" cy="2057400"/>
           </a:xfrm>
           <a:prstGeom prst="bentConnector3">
             <a:avLst/>
@@ -6171,13 +6305,13 @@
       </p:cxnSp>
       <p:sp>
         <p:nvSpPr>
-          <p:cNvPr id="80" name="Rectangle 79"/>
+          <p:cNvPr id="82" name="Rectangle 81"/>
           <p:cNvSpPr/>
           <p:nvPr/>
         </p:nvSpPr>
         <p:spPr>
           <a:xfrm>
-            <a:off x="1629918" y="4007358"/>
+            <a:off x="1401318" y="4053078"/>
             <a:ext cx="32004" cy="32004"/>
           </a:xfrm>
           <a:prstGeom prst="rect">
@@ -6213,14 +6347,14 @@
       </p:sp>
       <p:cxnSp>
         <p:nvCxnSpPr>
-          <p:cNvPr id="81" name="Connector 80"/>
+          <p:cNvPr id="83" name="Connector 82"/>
           <p:cNvCxnSpPr/>
           <p:nvPr/>
         </p:nvCxnSpPr>
         <p:spPr>
           <a:xfrm flipV="1">
-            <a:off x="3218688" y="4023360"/>
-            <a:ext cx="0" cy="1554480"/>
+            <a:off x="2880360" y="4069080"/>
+            <a:ext cx="0" cy="2057400"/>
           </a:xfrm>
           <a:prstGeom prst="bentConnector3">
             <a:avLst/>
@@ -6250,13 +6384,13 @@
       </p:cxnSp>
       <p:sp>
         <p:nvSpPr>
-          <p:cNvPr id="82" name="Rectangle 81"/>
+          <p:cNvPr id="84" name="Rectangle 83"/>
           <p:cNvSpPr/>
           <p:nvPr/>
         </p:nvSpPr>
         <p:spPr>
           <a:xfrm>
-            <a:off x="3202686" y="4007358"/>
+            <a:off x="2864358" y="4053078"/>
             <a:ext cx="32004" cy="32004"/>
           </a:xfrm>
           <a:prstGeom prst="rect">
@@ -6292,14 +6426,14 @@
       </p:sp>
       <p:cxnSp>
         <p:nvCxnSpPr>
-          <p:cNvPr id="83" name="Connector 82"/>
+          <p:cNvPr id="85" name="Connector 84"/>
           <p:cNvCxnSpPr/>
           <p:nvPr/>
         </p:nvCxnSpPr>
         <p:spPr>
           <a:xfrm flipV="1">
-            <a:off x="4791456" y="4023360"/>
-            <a:ext cx="0" cy="1554480"/>
+            <a:off x="4434840" y="4069080"/>
+            <a:ext cx="0" cy="2057400"/>
           </a:xfrm>
           <a:prstGeom prst="bentConnector3">
             <a:avLst/>
@@ -6329,13 +6463,13 @@
       </p:cxnSp>
       <p:sp>
         <p:nvSpPr>
-          <p:cNvPr id="84" name="Rectangle 83"/>
+          <p:cNvPr id="86" name="Rectangle 85"/>
           <p:cNvSpPr/>
           <p:nvPr/>
         </p:nvSpPr>
         <p:spPr>
           <a:xfrm>
-            <a:off x="4775454" y="4007358"/>
+            <a:off x="4418838" y="4053078"/>
             <a:ext cx="32004" cy="32004"/>
           </a:xfrm>
           <a:prstGeom prst="rect">
@@ -6371,14 +6505,14 @@
       </p:sp>
       <p:cxnSp>
         <p:nvCxnSpPr>
-          <p:cNvPr id="85" name="Connector 84"/>
+          <p:cNvPr id="87" name="Connector 86"/>
           <p:cNvCxnSpPr/>
           <p:nvPr/>
         </p:nvCxnSpPr>
         <p:spPr>
           <a:xfrm flipV="1">
-            <a:off x="6364224" y="4023360"/>
-            <a:ext cx="0" cy="1554480"/>
+            <a:off x="5897880" y="4069080"/>
+            <a:ext cx="0" cy="2057400"/>
           </a:xfrm>
           <a:prstGeom prst="bentConnector3">
             <a:avLst/>
@@ -6408,13 +6542,13 @@
       </p:cxnSp>
       <p:sp>
         <p:nvSpPr>
-          <p:cNvPr id="86" name="Rectangle 85"/>
+          <p:cNvPr id="88" name="Rectangle 87"/>
           <p:cNvSpPr/>
           <p:nvPr/>
         </p:nvSpPr>
         <p:spPr>
           <a:xfrm>
-            <a:off x="6348222" y="4007358"/>
+            <a:off x="5881878" y="4053078"/>
             <a:ext cx="32004" cy="32004"/>
           </a:xfrm>
           <a:prstGeom prst="rect">
@@ -6450,14 +6584,14 @@
       </p:sp>
       <p:cxnSp>
         <p:nvCxnSpPr>
-          <p:cNvPr id="87" name="Connector 86"/>
+          <p:cNvPr id="89" name="Connector 88"/>
           <p:cNvCxnSpPr/>
           <p:nvPr/>
         </p:nvCxnSpPr>
         <p:spPr>
           <a:xfrm flipV="1">
-            <a:off x="8183879" y="4869180"/>
-            <a:ext cx="0" cy="708660"/>
+            <a:off x="7955279" y="5486400"/>
+            <a:ext cx="0" cy="640080"/>
           </a:xfrm>
           <a:prstGeom prst="bentConnector3">
             <a:avLst/>
@@ -6487,13 +6621,13 @@
       </p:cxnSp>
       <p:sp>
         <p:nvSpPr>
-          <p:cNvPr id="88" name="Rectangle 87"/>
+          <p:cNvPr id="90" name="Rectangle 89"/>
           <p:cNvSpPr/>
           <p:nvPr/>
         </p:nvSpPr>
         <p:spPr>
           <a:xfrm>
-            <a:off x="8167877" y="4853178"/>
+            <a:off x="7939277" y="5470398"/>
             <a:ext cx="32004" cy="32004"/>
           </a:xfrm>
           <a:prstGeom prst="rect">
@@ -6529,14 +6663,14 @@
       </p:sp>
       <p:cxnSp>
         <p:nvCxnSpPr>
-          <p:cNvPr id="89" name="Connector 88"/>
+          <p:cNvPr id="91" name="Connector 90"/>
           <p:cNvCxnSpPr/>
           <p:nvPr/>
         </p:nvCxnSpPr>
         <p:spPr>
           <a:xfrm flipV="1">
-            <a:off x="7589520" y="3611880"/>
-            <a:ext cx="0" cy="1965960"/>
+            <a:off x="9098280" y="3291840"/>
+            <a:ext cx="0" cy="2834640"/>
           </a:xfrm>
           <a:prstGeom prst="bentConnector3">
             <a:avLst/>
@@ -6565,14 +6699,14 @@
       </p:cxnSp>
       <p:cxnSp>
         <p:nvCxnSpPr>
-          <p:cNvPr id="90" name="Connector 89"/>
+          <p:cNvPr id="92" name="Connector 91"/>
           <p:cNvCxnSpPr/>
           <p:nvPr/>
         </p:nvCxnSpPr>
         <p:spPr>
-          <a:xfrm>
-            <a:off x="7589520" y="3611880"/>
-            <a:ext cx="594359" cy="0"/>
+          <a:xfrm flipH="1">
+            <a:off x="7955279" y="3291840"/>
+            <a:ext cx="1143001" cy="0"/>
           </a:xfrm>
           <a:prstGeom prst="bentConnector3">
             <a:avLst/>
@@ -6601,14 +6735,14 @@
       </p:cxnSp>
       <p:cxnSp>
         <p:nvCxnSpPr>
-          <p:cNvPr id="91" name="Connector 90"/>
+          <p:cNvPr id="93" name="Connector 92"/>
           <p:cNvCxnSpPr/>
           <p:nvPr/>
         </p:nvCxnSpPr>
         <p:spPr>
           <a:xfrm flipV="1">
-            <a:off x="8183879" y="3177539"/>
-            <a:ext cx="0" cy="434341"/>
+            <a:off x="7955279" y="2834640"/>
+            <a:ext cx="0" cy="457200"/>
           </a:xfrm>
           <a:prstGeom prst="bentConnector3">
             <a:avLst/>
@@ -6638,13 +6772,13 @@
       </p:cxnSp>
       <p:sp>
         <p:nvSpPr>
-          <p:cNvPr id="92" name="Rectangle 91"/>
+          <p:cNvPr id="94" name="Rectangle 93"/>
           <p:cNvSpPr/>
           <p:nvPr/>
         </p:nvSpPr>
         <p:spPr>
           <a:xfrm>
-            <a:off x="8167877" y="3161537"/>
+            <a:off x="7939277" y="2818638"/>
             <a:ext cx="32004" cy="32004"/>
           </a:xfrm>
           <a:prstGeom prst="rect">
@@ -6680,14 +6814,14 @@
       </p:sp>
       <p:cxnSp>
         <p:nvCxnSpPr>
-          <p:cNvPr id="93" name="Connector 92"/>
+          <p:cNvPr id="95" name="Connector 94"/>
           <p:cNvCxnSpPr/>
           <p:nvPr/>
         </p:nvCxnSpPr>
         <p:spPr>
           <a:xfrm flipV="1">
-            <a:off x="3584448" y="4023360"/>
-            <a:ext cx="0" cy="1874520"/>
+            <a:off x="3429000" y="4069080"/>
+            <a:ext cx="0" cy="2377440"/>
           </a:xfrm>
           <a:prstGeom prst="bentConnector3">
             <a:avLst/>
@@ -6717,13 +6851,13 @@
       </p:cxnSp>
       <p:sp>
         <p:nvSpPr>
-          <p:cNvPr id="94" name="Rectangle 93"/>
+          <p:cNvPr id="96" name="Rectangle 95"/>
           <p:cNvSpPr/>
           <p:nvPr/>
         </p:nvSpPr>
         <p:spPr>
           <a:xfrm>
-            <a:off x="3568446" y="4007358"/>
+            <a:off x="3412998" y="4053078"/>
             <a:ext cx="32004" cy="32004"/>
           </a:xfrm>
           <a:prstGeom prst="rect">
@@ -6759,14 +6893,14 @@
       </p:sp>
       <p:cxnSp>
         <p:nvCxnSpPr>
-          <p:cNvPr id="95" name="Connector 94"/>
+          <p:cNvPr id="97" name="Connector 96"/>
           <p:cNvCxnSpPr/>
           <p:nvPr/>
         </p:nvCxnSpPr>
         <p:spPr>
           <a:xfrm flipV="1">
-            <a:off x="5157216" y="4023360"/>
-            <a:ext cx="0" cy="1874520"/>
+            <a:off x="4983480" y="4069080"/>
+            <a:ext cx="0" cy="2377440"/>
           </a:xfrm>
           <a:prstGeom prst="bentConnector3">
             <a:avLst/>
@@ -6796,13 +6930,13 @@
       </p:cxnSp>
       <p:sp>
         <p:nvSpPr>
-          <p:cNvPr id="96" name="Rectangle 95"/>
+          <p:cNvPr id="98" name="Rectangle 97"/>
           <p:cNvSpPr/>
           <p:nvPr/>
         </p:nvSpPr>
         <p:spPr>
           <a:xfrm>
-            <a:off x="5141214" y="4007358"/>
+            <a:off x="4967478" y="4053078"/>
             <a:ext cx="32004" cy="32004"/>
           </a:xfrm>
           <a:prstGeom prst="rect">
@@ -6838,14 +6972,14 @@
       </p:sp>
       <p:cxnSp>
         <p:nvCxnSpPr>
-          <p:cNvPr id="97" name="Connector 96"/>
+          <p:cNvPr id="99" name="Connector 98"/>
           <p:cNvCxnSpPr/>
           <p:nvPr/>
         </p:nvCxnSpPr>
         <p:spPr>
           <a:xfrm flipV="1">
-            <a:off x="2103120" y="4023360"/>
-            <a:ext cx="0" cy="2194560"/>
+            <a:off x="1920240" y="4069080"/>
+            <a:ext cx="0" cy="2697480"/>
           </a:xfrm>
           <a:prstGeom prst="bentConnector3">
             <a:avLst/>
@@ -6875,13 +7009,13 @@
       </p:cxnSp>
       <p:sp>
         <p:nvSpPr>
-          <p:cNvPr id="98" name="Rectangle 97"/>
+          <p:cNvPr id="100" name="Rectangle 99"/>
           <p:cNvSpPr/>
           <p:nvPr/>
         </p:nvSpPr>
         <p:spPr>
           <a:xfrm>
-            <a:off x="2087117" y="4007358"/>
+            <a:off x="1904238" y="4053078"/>
             <a:ext cx="32004" cy="32004"/>
           </a:xfrm>
           <a:prstGeom prst="rect">
@@ -6917,14 +7051,14 @@
       </p:sp>
       <p:cxnSp>
         <p:nvCxnSpPr>
-          <p:cNvPr id="99" name="Connector 98"/>
+          <p:cNvPr id="101" name="Connector 100"/>
           <p:cNvCxnSpPr/>
           <p:nvPr/>
         </p:nvCxnSpPr>
         <p:spPr>
           <a:xfrm flipV="1">
-            <a:off x="6729984" y="4023360"/>
-            <a:ext cx="0" cy="2194560"/>
+            <a:off x="6537960" y="4069080"/>
+            <a:ext cx="0" cy="2697480"/>
           </a:xfrm>
           <a:prstGeom prst="bentConnector3">
             <a:avLst/>
@@ -6954,13 +7088,13 @@
       </p:cxnSp>
       <p:sp>
         <p:nvSpPr>
-          <p:cNvPr id="100" name="Rectangle 99"/>
+          <p:cNvPr id="102" name="Rectangle 101"/>
           <p:cNvSpPr/>
           <p:nvPr/>
         </p:nvSpPr>
         <p:spPr>
           <a:xfrm>
-            <a:off x="6713982" y="4007358"/>
+            <a:off x="6521958" y="4053078"/>
             <a:ext cx="32004" cy="32004"/>
           </a:xfrm>
           <a:prstGeom prst="rect">
@@ -6996,14 +7130,14 @@
       </p:sp>
       <p:cxnSp>
         <p:nvCxnSpPr>
-          <p:cNvPr id="101" name="Connector 100"/>
+          <p:cNvPr id="103" name="Connector 102"/>
           <p:cNvCxnSpPr/>
           <p:nvPr/>
         </p:nvCxnSpPr>
         <p:spPr>
           <a:xfrm flipV="1">
-            <a:off x="8732520" y="4869180"/>
-            <a:ext cx="0" cy="1348740"/>
+            <a:off x="8595360" y="5486400"/>
+            <a:ext cx="0" cy="1280160"/>
           </a:xfrm>
           <a:prstGeom prst="bentConnector3">
             <a:avLst/>
@@ -7033,13 +7167,13 @@
       </p:cxnSp>
       <p:sp>
         <p:nvSpPr>
-          <p:cNvPr id="102" name="Rectangle 101"/>
+          <p:cNvPr id="104" name="Rectangle 103"/>
           <p:cNvSpPr/>
           <p:nvPr/>
         </p:nvSpPr>
         <p:spPr>
           <a:xfrm>
-            <a:off x="8716518" y="4853178"/>
+            <a:off x="8579358" y="5470398"/>
             <a:ext cx="32004" cy="32004"/>
           </a:xfrm>
           <a:prstGeom prst="rect">
@@ -7075,14 +7209,14 @@
       </p:sp>
       <p:cxnSp>
         <p:nvCxnSpPr>
-          <p:cNvPr id="103" name="Connector 102"/>
+          <p:cNvPr id="105" name="Connector 104"/>
           <p:cNvCxnSpPr/>
           <p:nvPr/>
         </p:nvCxnSpPr>
         <p:spPr>
           <a:xfrm flipV="1">
-            <a:off x="7772400" y="3703320"/>
-            <a:ext cx="0" cy="2514600"/>
+            <a:off x="9281160" y="3429000"/>
+            <a:ext cx="0" cy="3337560"/>
           </a:xfrm>
           <a:prstGeom prst="bentConnector3">
             <a:avLst/>
@@ -7111,14 +7245,14 @@
       </p:cxnSp>
       <p:cxnSp>
         <p:nvCxnSpPr>
-          <p:cNvPr id="104" name="Connector 103"/>
+          <p:cNvPr id="106" name="Connector 105"/>
           <p:cNvCxnSpPr/>
           <p:nvPr/>
         </p:nvCxnSpPr>
         <p:spPr>
-          <a:xfrm>
-            <a:off x="7772400" y="3703320"/>
-            <a:ext cx="960120" cy="0"/>
+          <a:xfrm flipH="1">
+            <a:off x="8595360" y="3429000"/>
+            <a:ext cx="685800" cy="0"/>
           </a:xfrm>
           <a:prstGeom prst="bentConnector3">
             <a:avLst/>
@@ -7147,14 +7281,14 @@
       </p:cxnSp>
       <p:cxnSp>
         <p:nvCxnSpPr>
-          <p:cNvPr id="105" name="Connector 104"/>
+          <p:cNvPr id="107" name="Connector 106"/>
           <p:cNvCxnSpPr/>
           <p:nvPr/>
         </p:nvCxnSpPr>
         <p:spPr>
           <a:xfrm flipV="1">
-            <a:off x="8732520" y="3177539"/>
-            <a:ext cx="0" cy="525781"/>
+            <a:off x="8595360" y="2834640"/>
+            <a:ext cx="0" cy="594360"/>
           </a:xfrm>
           <a:prstGeom prst="bentConnector3">
             <a:avLst/>
@@ -7184,13 +7318,13 @@
       </p:cxnSp>
       <p:sp>
         <p:nvSpPr>
-          <p:cNvPr id="106" name="Rectangle 105"/>
+          <p:cNvPr id="108" name="Rectangle 107"/>
           <p:cNvSpPr/>
           <p:nvPr/>
         </p:nvSpPr>
         <p:spPr>
           <a:xfrm>
-            <a:off x="8716518" y="3161537"/>
+            <a:off x="8579358" y="2818638"/>
             <a:ext cx="32004" cy="32004"/>
           </a:xfrm>
           <a:prstGeom prst="rect">
@@ -7226,14 +7360,14 @@
       </p:sp>
       <p:sp>
         <p:nvSpPr>
-          <p:cNvPr id="107" name="TextBox 106"/>
+          <p:cNvPr id="109" name="TextBox 108"/>
           <p:cNvSpPr txBox="1"/>
           <p:nvPr/>
         </p:nvSpPr>
         <p:spPr>
           <a:xfrm>
-            <a:off x="914400" y="6382512"/>
-            <a:ext cx="2651760" cy="365760"/>
+            <a:off x="914400" y="6903720"/>
+            <a:ext cx="2560320" cy="237744"/>
           </a:xfrm>
           <a:prstGeom prst="rect">
             <a:avLst/>
@@ -7241,7 +7375,7 @@
           <a:noFill/>
         </p:spPr>
         <p:txBody>
-          <a:bodyPr wrap="square" anchor="t" lIns="12700" rIns="12700" tIns="0" bIns="0">
+          <a:bodyPr wrap="square" anchor="t" lIns="12700" rIns="12700" tIns="12700" bIns="12700">
             <a:spAutoFit/>
           </a:bodyPr>
           <a:lstStyle/>
@@ -7260,14 +7394,14 @@
       </p:sp>
       <p:sp>
         <p:nvSpPr>
-          <p:cNvPr id="108" name="TextBox 107"/>
+          <p:cNvPr id="110" name="TextBox 109"/>
           <p:cNvSpPr txBox="1"/>
           <p:nvPr/>
         </p:nvSpPr>
         <p:spPr>
           <a:xfrm>
-            <a:off x="3749039" y="6382512"/>
-            <a:ext cx="2194560" cy="365760"/>
+            <a:off x="3657600" y="6903720"/>
+            <a:ext cx="2240280" cy="237744"/>
           </a:xfrm>
           <a:prstGeom prst="rect">
             <a:avLst/>
@@ -7275,7 +7409,7 @@
           <a:noFill/>
         </p:spPr>
         <p:txBody>
-          <a:bodyPr wrap="square" anchor="t" lIns="12700" rIns="12700" tIns="0" bIns="0">
+          <a:bodyPr wrap="square" anchor="t" lIns="12700" rIns="12700" tIns="12700" bIns="12700">
             <a:spAutoFit/>
           </a:bodyPr>
           <a:lstStyle/>
@@ -7294,14 +7428,14 @@
       </p:sp>
       <p:sp>
         <p:nvSpPr>
-          <p:cNvPr id="109" name="TextBox 108"/>
+          <p:cNvPr id="111" name="TextBox 110"/>
           <p:cNvSpPr txBox="1"/>
           <p:nvPr/>
         </p:nvSpPr>
         <p:spPr>
           <a:xfrm>
-            <a:off x="6035040" y="6382512"/>
-            <a:ext cx="3017520" cy="365760"/>
+            <a:off x="5943600" y="6903720"/>
+            <a:ext cx="2240280" cy="237744"/>
           </a:xfrm>
           <a:prstGeom prst="rect">
             <a:avLst/>
@@ -7309,7 +7443,7 @@
           <a:noFill/>
         </p:spPr>
         <p:txBody>
-          <a:bodyPr wrap="square" anchor="t" lIns="12700" rIns="12700" tIns="0" bIns="0">
+          <a:bodyPr wrap="square" anchor="t" lIns="12700" rIns="12700" tIns="12700" bIns="12700">
             <a:spAutoFit/>
           </a:bodyPr>
           <a:lstStyle/>
@@ -7322,142 +7456,6 @@
                 </a:solidFill>
               </a:rPr>
               <a:t>M3 DDS middleware and communications links</a:t>
-            </a:r>
-          </a:p>
-        </p:txBody>
-      </p:sp>
-      <p:sp>
-        <p:nvSpPr>
-          <p:cNvPr id="110" name="TextBox 109"/>
-          <p:cNvSpPr txBox="1"/>
-          <p:nvPr/>
-        </p:nvSpPr>
-        <p:spPr>
-          <a:xfrm>
-            <a:off x="182880" y="54864"/>
-            <a:ext cx="7680960" cy="411480"/>
-          </a:xfrm>
-          <a:prstGeom prst="rect">
-            <a:avLst/>
-          </a:prstGeom>
-          <a:noFill/>
-        </p:spPr>
-        <p:txBody>
-          <a:bodyPr wrap="square" anchor="t" lIns="12700" rIns="12700" tIns="0" bIns="0">
-            <a:spAutoFit/>
-          </a:bodyPr>
-          <a:lstStyle/>
-          <a:p>
-            <a:pPr algn="l"/>
-            <a:r>
-              <a:rPr sz="1500" b="1">
-                <a:solidFill>
-                  <a:srgbClr val="000000"/>
-                </a:solidFill>
-              </a:rPr>
-              <a:t>A0 — Decompose Conduct Air-Focused Weather Exploitation Operations</a:t>
-            </a:r>
-          </a:p>
-        </p:txBody>
-      </p:sp>
-      <p:sp>
-        <p:nvSpPr>
-          <p:cNvPr id="111" name="TextBox 110"/>
-          <p:cNvSpPr txBox="1"/>
-          <p:nvPr/>
-        </p:nvSpPr>
-        <p:spPr>
-          <a:xfrm>
-            <a:off x="7955279" y="54864"/>
-            <a:ext cx="1920240" cy="201168"/>
-          </a:xfrm>
-          <a:prstGeom prst="rect">
-            <a:avLst/>
-          </a:prstGeom>
-          <a:noFill/>
-        </p:spPr>
-        <p:txBody>
-          <a:bodyPr wrap="square" anchor="t" lIns="12700" rIns="12700" tIns="0" bIns="0">
-            <a:spAutoFit/>
-          </a:bodyPr>
-          <a:lstStyle/>
-          <a:p>
-            <a:pPr algn="r"/>
-            <a:r>
-              <a:rPr sz="1000" b="1">
-                <a:solidFill>
-                  <a:srgbClr val="000000"/>
-                </a:solidFill>
-              </a:rPr>
-              <a:t>Distribution Statement C</a:t>
-            </a:r>
-          </a:p>
-        </p:txBody>
-      </p:sp>
-      <p:sp>
-        <p:nvSpPr>
-          <p:cNvPr id="112" name="TextBox 111"/>
-          <p:cNvSpPr txBox="1"/>
-          <p:nvPr/>
-        </p:nvSpPr>
-        <p:spPr>
-          <a:xfrm>
-            <a:off x="7955279" y="246888"/>
-            <a:ext cx="1920240" cy="201168"/>
-          </a:xfrm>
-          <a:prstGeom prst="rect">
-            <a:avLst/>
-          </a:prstGeom>
-          <a:noFill/>
-        </p:spPr>
-        <p:txBody>
-          <a:bodyPr wrap="square" anchor="t" lIns="12700" rIns="12700" tIns="0" bIns="0">
-            <a:spAutoFit/>
-          </a:bodyPr>
-          <a:lstStyle/>
-          <a:p>
-            <a:pPr algn="r"/>
-            <a:r>
-              <a:rPr sz="1000" b="1">
-                <a:solidFill>
-                  <a:srgbClr val="000000"/>
-                </a:solidFill>
-              </a:rPr>
-              <a:t>Node: A0</a:t>
-            </a:r>
-          </a:p>
-        </p:txBody>
-      </p:sp>
-      <p:sp>
-        <p:nvSpPr>
-          <p:cNvPr id="113" name="TextBox 112"/>
-          <p:cNvSpPr txBox="1"/>
-          <p:nvPr/>
-        </p:nvSpPr>
-        <p:spPr>
-          <a:xfrm>
-            <a:off x="182880" y="7424927"/>
-            <a:ext cx="9692640" cy="274320"/>
-          </a:xfrm>
-          <a:prstGeom prst="rect">
-            <a:avLst/>
-          </a:prstGeom>
-          <a:noFill/>
-        </p:spPr>
-        <p:txBody>
-          <a:bodyPr wrap="square" anchor="t" lIns="12700" rIns="12700" tIns="0" bIns="0">
-            <a:spAutoFit/>
-          </a:bodyPr>
-          <a:lstStyle/>
-          <a:p>
-            <a:pPr algn="l"/>
-            <a:r>
-              <a:rPr sz="1000" b="0">
-                <a:solidFill>
-                  <a:srgbClr val="000000"/>
-                </a:solidFill>
-              </a:rPr>
-              <a:t>Node: A0     |     Distribution Statement C     |     Parent (A-0): Conduct Air-Focused Weather Exploitation Operations</a:t>
             </a:r>
           </a:p>
         </p:txBody>

</xml_diff>

<commit_message>
Refine A0 IDEF0 vNext label placement; add geometry preview renderer
Move F1/F2/F3 flow labels directly above their flow gaps (were
floating/disconnected); widen and reposition O2/O3 output labels above
and below their arrows, clear of arrowheads. Add render_preview.py to
rasterize the native pptx geometry for visual self-audit (not part of
the deliverable). Diagram verified: centered title, visible border,
Node:A0 cell, correct IDEF0 side semantics, perpendicular endpoints,
orthogonal elbow connectors, invisible ports, >=10pt fonts.

Co-Authored-By: Claude Opus 4.8 <noreply@anthropic.com>
Claude-Session: https://claude.ai/code/session_01HTptPbKo1SmoPv7tpyerKm
</commit_message>
<xml_diff>
--- a/ATMOS_A0_IDEF0_native_vNext.pptx
+++ b/ATMOS_A0_IDEF0_native_vNext.pptx
@@ -5617,8 +5617,8 @@
         </p:nvSpPr>
         <p:spPr>
           <a:xfrm>
-            <a:off x="1417320" y="2359152"/>
-            <a:ext cx="1783080" cy="384048"/>
+            <a:off x="1691640" y="2798064"/>
+            <a:ext cx="1463040" cy="530352"/>
           </a:xfrm>
           <a:prstGeom prst="rect">
             <a:avLst/>
@@ -5656,8 +5656,8 @@
         </p:nvSpPr>
         <p:spPr>
           <a:xfrm>
-            <a:off x="2971800" y="2670048"/>
-            <a:ext cx="1783080" cy="384048"/>
+            <a:off x="3200400" y="2798064"/>
+            <a:ext cx="1463040" cy="530352"/>
           </a:xfrm>
           <a:prstGeom prst="rect">
             <a:avLst/>
@@ -5695,8 +5695,8 @@
         </p:nvSpPr>
         <p:spPr>
           <a:xfrm>
-            <a:off x="4434840" y="2962656"/>
-            <a:ext cx="1783080" cy="384048"/>
+            <a:off x="4690872" y="2798064"/>
+            <a:ext cx="1463040" cy="530352"/>
           </a:xfrm>
           <a:prstGeom prst="rect">
             <a:avLst/>
@@ -5734,7 +5734,7 @@
         </p:nvSpPr>
         <p:spPr>
           <a:xfrm>
-            <a:off x="6967728" y="2980944"/>
+            <a:off x="6967728" y="2962656"/>
             <a:ext cx="1783080" cy="384048"/>
           </a:xfrm>
           <a:prstGeom prst="rect">
@@ -5773,7 +5773,7 @@
         </p:nvSpPr>
         <p:spPr>
           <a:xfrm>
-            <a:off x="6967728" y="4160520"/>
+            <a:off x="6967728" y="4187952"/>
             <a:ext cx="1783080" cy="384048"/>
           </a:xfrm>
           <a:prstGeom prst="rect">
@@ -6049,7 +6049,7 @@
         </p:nvSpPr>
         <p:spPr>
           <a:xfrm>
-            <a:off x="7589520" y="3456432"/>
+            <a:off x="7589520" y="3474720"/>
             <a:ext cx="1783080" cy="237744"/>
           </a:xfrm>
           <a:prstGeom prst="rect">
@@ -6088,8 +6088,8 @@
         </p:nvSpPr>
         <p:spPr>
           <a:xfrm>
-            <a:off x="8942832" y="2194560"/>
-            <a:ext cx="566928" cy="502920"/>
+            <a:off x="8942832" y="1938528"/>
+            <a:ext cx="768096" cy="502920"/>
           </a:xfrm>
           <a:prstGeom prst="rect">
             <a:avLst/>
@@ -6127,8 +6127,8 @@
         </p:nvSpPr>
         <p:spPr>
           <a:xfrm>
-            <a:off x="8942832" y="4846320"/>
-            <a:ext cx="566928" cy="502920"/>
+            <a:off x="8942832" y="5230368"/>
+            <a:ext cx="768096" cy="502920"/>
           </a:xfrm>
           <a:prstGeom prst="rect">
             <a:avLst/>

</xml_diff>